<commit_message>
docs: light cover and roomier limitations box in the proposal deck v3
Co-Authored-By: Claude Opus 5.5 <noreply@anthropic.com>
</commit_message>
<xml_diff>
--- a/docs/presentations/propuesta-ejecutiva-idm-test-framework-v3.pptx
+++ b/docs/presentations/propuesta-ejecutiva-idm-test-framework-v3.pptx
@@ -112,7 +112,7 @@
   <p:extLst>
     <p:ext uri="{521415D9-36F7-43E2-AB2F-B90AF26B5E84}">
       <p14:sectionLst xmlns:p14="http://schemas.microsoft.com/office/powerpoint/2010/main">
-        <p14:section name="Propuesta" id="{a100b58c-ee33-ea37-5adb-c5dc9aa2a777}">
+        <p14:section name="Propuesta" id="{2b07a5e9-ee82-5cbb-2534-15b7ad22def2}">
           <p14:sldIdLst>
             <p14:sldId id="256"/>
             <p14:sldId id="257"/>
@@ -120,7 +120,7 @@
             <p14:sldId id="259"/>
           </p14:sldIdLst>
         </p14:section>
-        <p14:section name="Respaldo" id="{09963719-3f9b-b128-d3ba-23fe861e0995}">
+        <p14:section name="Respaldo" id="{a557efc3-01e3-9966-de7e-b06953def3b4}">
           <p14:sldIdLst>
             <p14:sldId id="260"/>
             <p14:sldId id="261"/>
@@ -1048,7 +1048,7 @@
     <p:bg>
       <p:bgPr>
         <a:solidFill>
-          <a:schemeClr val="tx1"/>
+          <a:schemeClr val="bg1"/>
         </a:solidFill>
       </p:bgPr>
     </p:bg>
@@ -1092,7 +1092,7 @@
               <a:buNone/>
               <a:defRPr lang="en-US" sz="4400" b="1" dirty="0">
                 <a:solidFill>
-                  <a:schemeClr val="bg1"/>
+                  <a:schemeClr val="tx1"/>
                 </a:solidFill>
               </a:defRPr>
             </a:lvl1pPr>
@@ -1131,7 +1131,7 @@
               <a:buNone/>
               <a:defRPr lang="en-US" sz="2200" dirty="0">
                 <a:solidFill>
-                  <a:schemeClr val="accent5"/>
+                  <a:schemeClr val="accent1"/>
                 </a:solidFill>
               </a:defRPr>
             </a:lvl1pPr>
@@ -1713,7 +1713,7 @@
             <a:r>
               <a:rPr lang="en-US" sz="4400" b="1" dirty="0">
                 <a:solidFill>
-                  <a:schemeClr val="bg1"/>
+                  <a:schemeClr val="tx1"/>
                 </a:solidFill>
               </a:rPr>
               <a:t>Automatizar la validación de IdM</a:t>
@@ -1751,7 +1751,7 @@
             <a:r>
               <a:rPr lang="en-US" sz="2200" dirty="0">
                 <a:solidFill>
-                  <a:schemeClr val="accent5"/>
+                  <a:schemeClr val="accent1"/>
                 </a:solidFill>
               </a:rPr>
               <a:t>Una propuesta para Servicios Profesionales</a:t>
@@ -1787,7 +1787,7 @@
             <a:r>
               <a:rPr lang="en-US" sz="1800" dirty="0">
                 <a:solidFill>
-                  <a:schemeClr val="bg1"/>
+                  <a:schemeClr val="tx2"/>
                 </a:solidFill>
               </a:rPr>
               <a:t>Un solo flujo crea la identidad, asigna los accesos y comprueba el resultado en la base de datos y en Active Directory.</a:t>
@@ -1867,7 +1867,7 @@
             <a:r>
               <a:rPr lang="en-US" sz="1400" dirty="0">
                 <a:solidFill>
-                  <a:schemeClr val="bg1"/>
+                  <a:schemeClr val="tx1"/>
                 </a:solidFill>
               </a:rPr>
               <a:t>Escenarios reutilizables</a:t>
@@ -1947,7 +1947,7 @@
             <a:r>
               <a:rPr lang="en-US" sz="1400" dirty="0">
                 <a:solidFill>
-                  <a:schemeClr val="bg1"/>
+                  <a:schemeClr val="tx1"/>
                 </a:solidFill>
               </a:rPr>
               <a:t>Validación con espera</a:t>
@@ -2027,7 +2027,7 @@
             <a:r>
               <a:rPr lang="en-US" sz="1400" dirty="0">
                 <a:solidFill>
-                  <a:schemeClr val="bg1"/>
+                  <a:schemeClr val="tx1"/>
                 </a:solidFill>
               </a:rPr>
               <a:t>Evidencia por ejecución</a:t>
@@ -2038,7 +2038,29 @@
       </p:sp>
       <p:sp>
         <p:nvSpPr>
-          <p:cNvPr id="14" name="Flow line"/>
+          <p:cNvPr id="14" name="Flow panel"/>
+          <p:cNvSpPr/>
+          <p:nvPr/>
+        </p:nvSpPr>
+        <p:spPr>
+          <a:xfrm>
+            <a:off x="8321040" y="731520"/>
+            <a:ext cx="3322015" cy="5303520"/>
+          </a:xfrm>
+          <a:prstGeom prst="roundRect">
+            <a:avLst>
+              <a:gd name="adj" fmla="val 3303"/>
+            </a:avLst>
+          </a:prstGeom>
+          <a:solidFill>
+            <a:srgbClr val="EEF3F9"/>
+          </a:solidFill>
+          <a:ln/>
+        </p:spPr>
+      </p:sp>
+      <p:sp>
+        <p:nvSpPr>
+          <p:cNvPr id="15" name="Flow line"/>
           <p:cNvSpPr/>
           <p:nvPr/>
         </p:nvSpPr>
@@ -2061,7 +2083,7 @@
       </p:sp>
       <p:sp>
         <p:nvSpPr>
-          <p:cNvPr id="15" name="Identidad en IdM circle"/>
+          <p:cNvPr id="16" name="Identidad en IdM circle"/>
           <p:cNvSpPr/>
           <p:nvPr/>
         </p:nvSpPr>
@@ -2081,7 +2103,7 @@
       </p:sp>
       <p:pic>
         <p:nvPicPr>
-          <p:cNvPr id="16" name="Identidad en IdM icon" descr="Identidad en IdM">    </p:cNvPr>
+          <p:cNvPr id="17" name="Identidad en IdM icon" descr="Identidad en IdM">    </p:cNvPr>
           <p:cNvPicPr>
             <a:picLocks noChangeAspect="1"/>
           </p:cNvPicPr>
@@ -2105,7 +2127,7 @@
       </p:pic>
       <p:sp>
         <p:nvSpPr>
-          <p:cNvPr id="17" name="Identidad en IdM label"/>
+          <p:cNvPr id="18" name="Identidad en IdM label"/>
           <p:cNvSpPr txBox="1"/>
           <p:nvPr/>
         </p:nvSpPr>
@@ -2130,7 +2152,7 @@
             <a:r>
               <a:rPr lang="en-US" sz="1600" b="1" dirty="0">
                 <a:solidFill>
-                  <a:schemeClr val="bg1"/>
+                  <a:schemeClr val="tx1"/>
                 </a:solidFill>
               </a:rPr>
               <a:t>Identidad en IdM</a:t>
@@ -2141,7 +2163,7 @@
       </p:sp>
       <p:sp>
         <p:nvSpPr>
-          <p:cNvPr id="18" name="Accesos asignados circle"/>
+          <p:cNvPr id="19" name="Accesos asignados circle"/>
           <p:cNvSpPr/>
           <p:nvPr/>
         </p:nvSpPr>
@@ -2161,7 +2183,7 @@
       </p:sp>
       <p:pic>
         <p:nvPicPr>
-          <p:cNvPr id="19" name="Accesos asignados icon" descr="Accesos asignados">    </p:cNvPr>
+          <p:cNvPr id="20" name="Accesos asignados icon" descr="Accesos asignados">    </p:cNvPr>
           <p:cNvPicPr>
             <a:picLocks noChangeAspect="1"/>
           </p:cNvPicPr>
@@ -2185,7 +2207,7 @@
       </p:pic>
       <p:sp>
         <p:nvSpPr>
-          <p:cNvPr id="20" name="Accesos asignados label"/>
+          <p:cNvPr id="21" name="Accesos asignados label"/>
           <p:cNvSpPr txBox="1"/>
           <p:nvPr/>
         </p:nvSpPr>
@@ -2210,7 +2232,7 @@
             <a:r>
               <a:rPr lang="en-US" sz="1600" b="1" dirty="0">
                 <a:solidFill>
-                  <a:schemeClr val="bg1"/>
+                  <a:schemeClr val="tx1"/>
                 </a:solidFill>
               </a:rPr>
               <a:t>Accesos asignados</a:t>
@@ -2221,7 +2243,7 @@
       </p:sp>
       <p:sp>
         <p:nvSpPr>
-          <p:cNvPr id="21" name="Base de datos circle"/>
+          <p:cNvPr id="22" name="Base de datos circle"/>
           <p:cNvSpPr/>
           <p:nvPr/>
         </p:nvSpPr>
@@ -2241,7 +2263,7 @@
       </p:sp>
       <p:pic>
         <p:nvPicPr>
-          <p:cNvPr id="22" name="Base de datos icon" descr="Base de datos">    </p:cNvPr>
+          <p:cNvPr id="23" name="Base de datos icon" descr="Base de datos">    </p:cNvPr>
           <p:cNvPicPr>
             <a:picLocks noChangeAspect="1"/>
           </p:cNvPicPr>
@@ -2265,7 +2287,7 @@
       </p:pic>
       <p:sp>
         <p:nvSpPr>
-          <p:cNvPr id="23" name="Base de datos label"/>
+          <p:cNvPr id="24" name="Base de datos label"/>
           <p:cNvSpPr txBox="1"/>
           <p:nvPr/>
         </p:nvSpPr>
@@ -2290,7 +2312,7 @@
             <a:r>
               <a:rPr lang="en-US" sz="1600" b="1" dirty="0">
                 <a:solidFill>
-                  <a:schemeClr val="bg1"/>
+                  <a:schemeClr val="tx1"/>
                 </a:solidFill>
               </a:rPr>
               <a:t>Base de datos</a:t>
@@ -2301,7 +2323,7 @@
       </p:sp>
       <p:sp>
         <p:nvSpPr>
-          <p:cNvPr id="24" name="Active Directory circle"/>
+          <p:cNvPr id="25" name="Active Directory circle"/>
           <p:cNvSpPr/>
           <p:nvPr/>
         </p:nvSpPr>
@@ -2321,7 +2343,7 @@
       </p:sp>
       <p:pic>
         <p:nvPicPr>
-          <p:cNvPr id="25" name="Active Directory icon" descr="Active Directory">    </p:cNvPr>
+          <p:cNvPr id="26" name="Active Directory icon" descr="Active Directory">    </p:cNvPr>
           <p:cNvPicPr>
             <a:picLocks noChangeAspect="1"/>
           </p:cNvPicPr>
@@ -2345,7 +2367,7 @@
       </p:pic>
       <p:sp>
         <p:nvSpPr>
-          <p:cNvPr id="26" name="Active Directory label"/>
+          <p:cNvPr id="27" name="Active Directory label"/>
           <p:cNvSpPr txBox="1"/>
           <p:nvPr/>
         </p:nvSpPr>
@@ -2370,7 +2392,7 @@
             <a:r>
               <a:rPr lang="en-US" sz="1600" b="1" dirty="0">
                 <a:solidFill>
-                  <a:schemeClr val="bg1"/>
+                  <a:schemeClr val="tx1"/>
                 </a:solidFill>
               </a:rPr>
               <a:t>Active Directory</a:t>
@@ -3026,7 +3048,7 @@
                   </a:tcPr>
                 </a:tc>
               </a:tr>
-              <a:tr h="548640">
+              <a:tr h="493776">
                 <a:tc>
                   <a:txBody>
                     <a:bodyPr/>
@@ -3202,7 +3224,7 @@
                   </a:tcPr>
                 </a:tc>
               </a:tr>
-              <a:tr h="548640">
+              <a:tr h="493776">
                 <a:tc>
                   <a:txBody>
                     <a:bodyPr/>
@@ -3378,7 +3400,7 @@
                   </a:tcPr>
                 </a:tc>
               </a:tr>
-              <a:tr h="548640">
+              <a:tr h="493776">
                 <a:tc>
                   <a:txBody>
                     <a:bodyPr/>
@@ -3554,7 +3576,7 @@
                   </a:tcPr>
                 </a:tc>
               </a:tr>
-              <a:tr h="548640">
+              <a:tr h="493776">
                 <a:tc>
                   <a:txBody>
                     <a:bodyPr/>
@@ -3730,7 +3752,7 @@
                   </a:tcPr>
                 </a:tc>
               </a:tr>
-              <a:tr h="548640">
+              <a:tr h="493776">
                 <a:tc>
                   <a:txBody>
                     <a:bodyPr/>
@@ -3918,16 +3940,16 @@
         </p:nvSpPr>
         <p:spPr>
           <a:xfrm>
-            <a:off x="4389120" y="4572000"/>
-            <a:ext cx="7253935" cy="1600200"/>
+            <a:off x="4389120" y="4800600"/>
+            <a:ext cx="7253935" cy="1371600"/>
           </a:xfrm>
           <a:prstGeom prst="roundRect">
             <a:avLst>
-              <a:gd name="adj" fmla="val 6857"/>
+              <a:gd name="adj" fmla="val 8000"/>
             </a:avLst>
           </a:prstGeom>
           <a:solidFill>
-            <a:srgbClr val="FBEFE2"/>
+            <a:srgbClr val="F7D9B5"/>
           </a:solidFill>
           <a:ln/>
         </p:spPr>
@@ -3940,7 +3962,7 @@
         </p:nvSpPr>
         <p:spPr>
           <a:xfrm>
-            <a:off x="4663440" y="4846320"/>
+            <a:off x="4663440" y="4983480"/>
             <a:ext cx="502920" cy="502920"/>
           </a:xfrm>
           <a:prstGeom prst="ellipse">
@@ -3968,7 +3990,7 @@
         </p:blipFill>
         <p:spPr>
           <a:xfrm>
-            <a:off x="4789170" y="4972050"/>
+            <a:off x="4789170" y="5109210"/>
             <a:ext cx="251460" cy="251460"/>
           </a:xfrm>
           <a:prstGeom prst="rect">
@@ -3984,7 +4006,7 @@
         </p:nvSpPr>
         <p:spPr>
           <a:xfrm>
-            <a:off x="5349240" y="4846320"/>
+            <a:off x="5349240" y="4983480"/>
             <a:ext cx="3657600" cy="502920"/>
           </a:xfrm>
           <a:prstGeom prst="rect">
@@ -4003,7 +4025,7 @@
             <a:r>
               <a:rPr lang="en-US" sz="1400" b="1" dirty="0">
                 <a:solidFill>
-                  <a:srgbClr val="9A5410"/>
+                  <a:srgbClr val="7A3F08"/>
                 </a:solidFill>
               </a:rPr>
               <a:t>LIMITACIONES ACTUALES</a:t>
@@ -4020,8 +4042,8 @@
         </p:nvSpPr>
         <p:spPr>
           <a:xfrm>
-            <a:off x="4663440" y="5486400"/>
-            <a:ext cx="3200400" cy="594360"/>
+            <a:off x="4663440" y="5577840"/>
+            <a:ext cx="3200400" cy="548640"/>
           </a:xfrm>
           <a:prstGeom prst="rect">
             <a:avLst/>
@@ -4078,8 +4100,8 @@
         </p:nvSpPr>
         <p:spPr>
           <a:xfrm>
-            <a:off x="8229600" y="5486400"/>
-            <a:ext cx="3200400" cy="594360"/>
+            <a:off x="8229600" y="5577840"/>
+            <a:ext cx="3200400" cy="548640"/>
           </a:xfrm>
           <a:prstGeom prst="rect">
             <a:avLst/>

</xml_diff>